<commit_message>
fix: render *italic* spans in the technical deck instead of literal asterisks
rich() handled **bold** and `mono` but not single-asterisk italics, so two
phrases carried visible asterisks onto slides 2 and 3.

Claude-Session: https://claude.ai/code/session_01YWigqjn9Pr9kDRf8J6GSvy
</commit_message>
<xml_diff>
--- a/reports/decks/technical_deck.pptx
+++ b/reports/decks/technical_deck.pptx
@@ -3297,7 +3297,7 @@
               </a:lnSpc>
             </a:pPr>
             <a:r>
-              <a:rPr sz="1200" b="1">
+              <a:rPr sz="1200" b="1" i="0">
                 <a:solidFill>
                   <a:srgbClr val="FFFFFF"/>
                 </a:solidFill>
@@ -3306,7 +3306,7 @@
               <a:t>Question.</a:t>
             </a:r>
             <a:r>
-              <a:rPr sz="1200" b="0">
+              <a:rPr sz="1200" b="0" i="0">
                 <a:solidFill>
                   <a:srgbClr val="D6E0EC"/>
                 </a:solidFill>
@@ -3345,7 +3345,7 @@
               </a:lnSpc>
             </a:pPr>
             <a:r>
-              <a:rPr sz="1200" b="1">
+              <a:rPr sz="1200" b="1" i="0">
                 <a:solidFill>
                   <a:srgbClr val="FFFFFF"/>
                 </a:solidFill>
@@ -3354,7 +3354,7 @@
               <a:t>Answer in one line.</a:t>
             </a:r>
             <a:r>
-              <a:rPr sz="1200" b="0">
+              <a:rPr sz="1200" b="0" i="0">
                 <a:solidFill>
                   <a:srgbClr val="D6E0EC"/>
                 </a:solidFill>
@@ -3615,7 +3615,7 @@
                         </a:lnSpc>
                       </a:pPr>
                       <a:r>
-                        <a:rPr sz="825" b="1" spc="130">
+                        <a:rPr sz="825" b="1" i="0" spc="130">
                           <a:solidFill>
                             <a:srgbClr val="5B6B7B"/>
                           </a:solidFill>
@@ -3647,7 +3647,7 @@
                         </a:lnSpc>
                       </a:pPr>
                       <a:r>
-                        <a:rPr sz="825" b="1" spc="130">
+                        <a:rPr sz="825" b="1" i="0" spc="130">
                           <a:solidFill>
                             <a:srgbClr val="5B6B7B"/>
                           </a:solidFill>
@@ -3679,7 +3679,7 @@
                         </a:lnSpc>
                       </a:pPr>
                       <a:r>
-                        <a:rPr sz="825" b="1" spc="130">
+                        <a:rPr sz="825" b="1" i="0" spc="130">
                           <a:solidFill>
                             <a:srgbClr val="5B6B7B"/>
                           </a:solidFill>
@@ -3711,7 +3711,7 @@
                         </a:lnSpc>
                       </a:pPr>
                       <a:r>
-                        <a:rPr sz="825" b="1" spc="130">
+                        <a:rPr sz="825" b="1" i="0" spc="130">
                           <a:solidFill>
                             <a:srgbClr val="5B6B7B"/>
                           </a:solidFill>
@@ -3745,7 +3745,7 @@
                         </a:lnSpc>
                       </a:pPr>
                       <a:r>
-                        <a:rPr sz="1125" b="0">
+                        <a:rPr sz="1125" b="0" i="0">
                           <a:solidFill>
                             <a:srgbClr val="1D2A3A"/>
                           </a:solidFill>
@@ -3777,7 +3777,7 @@
                         </a:lnSpc>
                       </a:pPr>
                       <a:r>
-                        <a:rPr sz="1125" b="0">
+                        <a:rPr sz="1125" b="0" i="0">
                           <a:solidFill>
                             <a:srgbClr val="1D2A3A"/>
                           </a:solidFill>
@@ -3809,7 +3809,7 @@
                         </a:lnSpc>
                       </a:pPr>
                       <a:r>
-                        <a:rPr sz="1125" b="0">
+                        <a:rPr sz="1125" b="0" i="0">
                           <a:solidFill>
                             <a:srgbClr val="1D2A3A"/>
                           </a:solidFill>
@@ -3841,7 +3841,7 @@
                         </a:lnSpc>
                       </a:pPr>
                       <a:r>
-                        <a:rPr sz="1125" b="0">
+                        <a:rPr sz="1125" b="0" i="0">
                           <a:solidFill>
                             <a:srgbClr val="1D2A3A"/>
                           </a:solidFill>
@@ -3875,7 +3875,7 @@
                         </a:lnSpc>
                       </a:pPr>
                       <a:r>
-                        <a:rPr sz="1125" b="0">
+                        <a:rPr sz="1125" b="0" i="0">
                           <a:solidFill>
                             <a:srgbClr val="1D2A3A"/>
                           </a:solidFill>
@@ -3907,7 +3907,7 @@
                         </a:lnSpc>
                       </a:pPr>
                       <a:r>
-                        <a:rPr sz="1125" b="0">
+                        <a:rPr sz="1125" b="0" i="0">
                           <a:solidFill>
                             <a:srgbClr val="1D2A3A"/>
                           </a:solidFill>
@@ -3939,7 +3939,7 @@
                         </a:lnSpc>
                       </a:pPr>
                       <a:r>
-                        <a:rPr sz="1125" b="0">
+                        <a:rPr sz="1125" b="0" i="0">
                           <a:solidFill>
                             <a:srgbClr val="1D2A3A"/>
                           </a:solidFill>
@@ -3971,7 +3971,7 @@
                         </a:lnSpc>
                       </a:pPr>
                       <a:r>
-                        <a:rPr sz="1125" b="1">
+                        <a:rPr sz="1125" b="1" i="0">
                           <a:solidFill>
                             <a:srgbClr val="AA3333"/>
                           </a:solidFill>
@@ -4034,7 +4034,7 @@
               <a:t>—  </a:t>
             </a:r>
             <a:r>
-              <a:rPr sz="1125" b="0">
+              <a:rPr sz="1125" b="0" i="0">
                 <a:solidFill>
                   <a:srgbClr val="1D2A3A"/>
                 </a:solidFill>
@@ -4062,7 +4062,7 @@
               <a:t>—  </a:t>
             </a:r>
             <a:r>
-              <a:rPr sz="1125" b="1">
+              <a:rPr sz="1125" b="1" i="0">
                 <a:solidFill>
                   <a:srgbClr val="1F3A5F"/>
                 </a:solidFill>
@@ -4071,7 +4071,7 @@
               <a:t>Age: the material finding.</a:t>
             </a:r>
             <a:r>
-              <a:rPr sz="1125" b="0">
+              <a:rPr sz="1125" b="0" i="0">
                 <a:solidFill>
                   <a:srgbClr val="1D2A3A"/>
                 </a:solidFill>
@@ -4099,7 +4099,7 @@
               <a:t>—  </a:t>
             </a:r>
             <a:r>
-              <a:rPr sz="1125" b="0">
+              <a:rPr sz="1125" b="0" i="0">
                 <a:solidFill>
                   <a:srgbClr val="1D2A3A"/>
                 </a:solidFill>
@@ -4127,7 +4127,7 @@
               <a:t>—  </a:t>
             </a:r>
             <a:r>
-              <a:rPr sz="1125" b="0">
+              <a:rPr sz="1125" b="0" i="0">
                 <a:solidFill>
                   <a:srgbClr val="1D2A3A"/>
                 </a:solidFill>
@@ -4433,7 +4433,7 @@
               <a:t>—  </a:t>
             </a:r>
             <a:r>
-              <a:rPr sz="1200" b="0">
+              <a:rPr sz="1200" b="0" i="0">
                 <a:solidFill>
                   <a:srgbClr val="1D2A3A"/>
                 </a:solidFill>
@@ -4442,7 +4442,7 @@
               <a:t>Single seed (42), config-driven CLI (</a:t>
             </a:r>
             <a:r>
-              <a:rPr sz="1125" b="0">
+              <a:rPr sz="1125" b="0" i="0">
                 <a:solidFill>
                   <a:srgbClr val="1D2A3A"/>
                 </a:solidFill>
@@ -4451,7 +4451,7 @@
               <a:t>python -m ssn …</a:t>
             </a:r>
             <a:r>
-              <a:rPr sz="1200" b="0">
+              <a:rPr sz="1200" b="0" i="0">
                 <a:solidFill>
                   <a:srgbClr val="1D2A3A"/>
                 </a:solidFill>
@@ -4460,7 +4460,7 @@
               <a:t>), pinned </a:t>
             </a:r>
             <a:r>
-              <a:rPr sz="1125" b="0">
+              <a:rPr sz="1125" b="0" i="0">
                 <a:solidFill>
                   <a:srgbClr val="1D2A3A"/>
                 </a:solidFill>
@@ -4469,7 +4469,7 @@
               <a:t>requirements.txt</a:t>
             </a:r>
             <a:r>
-              <a:rPr sz="1200" b="0">
+              <a:rPr sz="1200" b="0" i="0">
                 <a:solidFill>
                   <a:srgbClr val="1D2A3A"/>
                 </a:solidFill>
@@ -4478,7 +4478,7 @@
               <a:t>, </a:t>
             </a:r>
             <a:r>
-              <a:rPr sz="1125" b="0">
+              <a:rPr sz="1125" b="0" i="0">
                 <a:solidFill>
                   <a:srgbClr val="1D2A3A"/>
                 </a:solidFill>
@@ -4487,7 +4487,7 @@
               <a:t>n_jobs=1</a:t>
             </a:r>
             <a:r>
-              <a:rPr sz="1200" b="0">
+              <a:rPr sz="1200" b="0" i="0">
                 <a:solidFill>
                   <a:srgbClr val="1D2A3A"/>
                 </a:solidFill>
@@ -4515,7 +4515,7 @@
               <a:t>—  </a:t>
             </a:r>
             <a:r>
-              <a:rPr sz="1200" b="0">
+              <a:rPr sz="1200" b="0" i="0">
                 <a:solidFill>
                   <a:srgbClr val="1D2A3A"/>
                 </a:solidFill>
@@ -4543,7 +4543,7 @@
               <a:t>—  </a:t>
             </a:r>
             <a:r>
-              <a:rPr sz="1200" b="1">
+              <a:rPr sz="1200" b="1" i="0">
                 <a:solidFill>
                   <a:srgbClr val="1F3A5F"/>
                 </a:solidFill>
@@ -4552,7 +4552,7 @@
               <a:t>Fresh-environment re-run: maximum absolute delta 0</a:t>
             </a:r>
             <a:r>
-              <a:rPr sz="1200" b="0">
+              <a:rPr sz="1200" b="0" i="0">
                 <a:solidFill>
                   <a:srgbClr val="1D2A3A"/>
                 </a:solidFill>
@@ -4561,7 +4561,7 @@
               <a:t> across every compared table (</a:t>
             </a:r>
             <a:r>
-              <a:rPr sz="1125" b="0">
+              <a:rPr sz="1125" b="0" i="0">
                 <a:solidFill>
                   <a:srgbClr val="1D2A3A"/>
                 </a:solidFill>
@@ -4570,7 +4570,7 @@
               <a:t>docs/REPRODUCIBILITY.md</a:t>
             </a:r>
             <a:r>
-              <a:rPr sz="1200" b="0">
+              <a:rPr sz="1200" b="0" i="0">
                 <a:solidFill>
                   <a:srgbClr val="1D2A3A"/>
                 </a:solidFill>
@@ -4598,7 +4598,7 @@
               <a:t>—  </a:t>
             </a:r>
             <a:r>
-              <a:rPr sz="1200" b="1">
+              <a:rPr sz="1200" b="1" i="0">
                 <a:solidFill>
                   <a:srgbClr val="1F3A5F"/>
                 </a:solidFill>
@@ -4607,7 +4607,7 @@
               <a:t>215 automated tests:</a:t>
             </a:r>
             <a:r>
-              <a:rPr sz="1200" b="0">
+              <a:rPr sz="1200" b="0" i="0">
                 <a:solidFill>
                   <a:srgbClr val="1D2A3A"/>
                 </a:solidFill>
@@ -4913,7 +4913,7 @@
               <a:t>—  </a:t>
             </a:r>
             <a:r>
-              <a:rPr sz="1200" b="1">
+              <a:rPr sz="1200" b="1" i="0">
                 <a:solidFill>
                   <a:srgbClr val="1F3A5F"/>
                 </a:solidFill>
@@ -4922,7 +4922,7 @@
               <a:t>Scope:</a:t>
             </a:r>
             <a:r>
-              <a:rPr sz="1200" b="0">
+              <a:rPr sz="1200" b="0" i="0">
                 <a:solidFill>
                   <a:srgbClr val="1D2A3A"/>
                 </a:solidFill>
@@ -4950,7 +4950,7 @@
               <a:t>—  </a:t>
             </a:r>
             <a:r>
-              <a:rPr sz="1200" b="1">
+              <a:rPr sz="1200" b="1" i="0">
                 <a:solidFill>
                   <a:srgbClr val="1F3A5F"/>
                 </a:solidFill>
@@ -4959,7 +4959,7 @@
               <a:t>Proxies:</a:t>
             </a:r>
             <a:r>
-              <a:rPr sz="1200" b="0">
+              <a:rPr sz="1200" b="0" i="0">
                 <a:solidFill>
                   <a:srgbClr val="1D2A3A"/>
                 </a:solidFill>
@@ -4987,7 +4987,7 @@
               <a:t>—  </a:t>
             </a:r>
             <a:r>
-              <a:rPr sz="1200" b="1">
+              <a:rPr sz="1200" b="1" i="0">
                 <a:solidFill>
                   <a:srgbClr val="1F3A5F"/>
                 </a:solidFill>
@@ -4996,7 +4996,7 @@
               <a:t>Leakage guard cost:</a:t>
             </a:r>
             <a:r>
-              <a:rPr sz="1200" b="0">
+              <a:rPr sz="1200" b="0" i="0">
                 <a:solidFill>
                   <a:srgbClr val="1D2A3A"/>
                 </a:solidFill>
@@ -5024,7 +5024,7 @@
               <a:t>—  </a:t>
             </a:r>
             <a:r>
-              <a:rPr sz="1200" b="1">
+              <a:rPr sz="1200" b="1" i="0">
                 <a:solidFill>
                   <a:srgbClr val="1F3A5F"/>
                 </a:solidFill>
@@ -5033,7 +5033,7 @@
               <a:t>Uncertainty:</a:t>
             </a:r>
             <a:r>
-              <a:rPr sz="1200" b="0">
+              <a:rPr sz="1200" b="0" i="0">
                 <a:solidFill>
                   <a:srgbClr val="1D2A3A"/>
                 </a:solidFill>
@@ -5061,7 +5061,7 @@
               <a:t>—  </a:t>
             </a:r>
             <a:r>
-              <a:rPr sz="1200" b="1">
+              <a:rPr sz="1200" b="1" i="0">
                 <a:solidFill>
                   <a:srgbClr val="1F3A5F"/>
                 </a:solidFill>
@@ -5070,7 +5070,7 @@
               <a:t>Not causal, not production-ready, not a replacement for advisers:</a:t>
             </a:r>
             <a:r>
-              <a:rPr sz="1200" b="0">
+              <a:rPr sz="1200" b="0" i="0">
                 <a:solidFill>
                   <a:srgbClr val="1D2A3A"/>
                 </a:solidFill>
@@ -5098,7 +5098,7 @@
               <a:t>—  </a:t>
             </a:r>
             <a:r>
-              <a:rPr sz="1200" b="0">
+              <a:rPr sz="1200" b="0" i="0">
                 <a:solidFill>
                   <a:srgbClr val="1D2A3A"/>
                 </a:solidFill>
@@ -5107,7 +5107,7 @@
               <a:t>Full text: </a:t>
             </a:r>
             <a:r>
-              <a:rPr sz="1125" b="0">
+              <a:rPr sz="1125" b="0" i="0">
                 <a:solidFill>
                   <a:srgbClr val="1D2A3A"/>
                 </a:solidFill>
@@ -5116,7 +5116,7 @@
               <a:t>reports/limitations.md</a:t>
             </a:r>
             <a:r>
-              <a:rPr sz="1200" b="0">
+              <a:rPr sz="1200" b="0" i="0">
                 <a:solidFill>
                   <a:srgbClr val="1D2A3A"/>
                 </a:solidFill>
@@ -5125,7 +5125,7 @@
               <a:t>, </a:t>
             </a:r>
             <a:r>
-              <a:rPr sz="1125" b="0">
+              <a:rPr sz="1125" b="0" i="0">
                 <a:solidFill>
                   <a:srgbClr val="1D2A3A"/>
                 </a:solidFill>
@@ -5134,7 +5134,7 @@
               <a:t>reports/bias_fairness_analysis.md</a:t>
             </a:r>
             <a:r>
-              <a:rPr sz="1200" b="0">
+              <a:rPr sz="1200" b="0" i="0">
                 <a:solidFill>
                   <a:srgbClr val="1D2A3A"/>
                 </a:solidFill>
@@ -5143,7 +5143,7 @@
               <a:t>, </a:t>
             </a:r>
             <a:r>
-              <a:rPr sz="1125" b="0">
+              <a:rPr sz="1125" b="0" i="0">
                 <a:solidFill>
                   <a:srgbClr val="1D2A3A"/>
                 </a:solidFill>
@@ -5449,7 +5449,7 @@
               <a:t>—  </a:t>
             </a:r>
             <a:r>
-              <a:rPr sz="1200" b="1">
+              <a:rPr sz="1200" b="1" i="0">
                 <a:solidFill>
                   <a:srgbClr val="1F3A5F"/>
                 </a:solidFill>
@@ -5458,7 +5458,7 @@
               <a:t>Unit of analysis:</a:t>
             </a:r>
             <a:r>
-              <a:rPr sz="1200" b="0">
+              <a:rPr sz="1200" b="0" i="0">
                 <a:solidFill>
                   <a:srgbClr val="1D2A3A"/>
                 </a:solidFill>
@@ -5467,7 +5467,7 @@
               <a:t> one student enrollment record · </a:t>
             </a:r>
             <a:r>
-              <a:rPr sz="1200" b="1">
+              <a:rPr sz="1200" b="1" i="0">
                 <a:solidFill>
                   <a:srgbClr val="1F3A5F"/>
                 </a:solidFill>
@@ -5476,7 +5476,7 @@
               <a:t>Prediction point:</a:t>
             </a:r>
             <a:r>
-              <a:rPr sz="1200" b="0">
+              <a:rPr sz="1200" b="0" i="0">
                 <a:solidFill>
                   <a:srgbClr val="1D2A3A"/>
                 </a:solidFill>
@@ -5504,7 +5504,7 @@
               <a:t>—  </a:t>
             </a:r>
             <a:r>
-              <a:rPr sz="1200" b="1">
+              <a:rPr sz="1200" b="1" i="0">
                 <a:solidFill>
                   <a:srgbClr val="1F3A5F"/>
                 </a:solidFill>
@@ -5513,7 +5513,7 @@
               <a:t>Task:</a:t>
             </a:r>
             <a:r>
-              <a:rPr sz="1200" b="0">
+              <a:rPr sz="1200" b="0" i="0">
                 <a:solidFill>
                   <a:srgbClr val="1D2A3A"/>
                 </a:solidFill>
@@ -5522,7 +5522,7 @@
               <a:t> binary classification, </a:t>
             </a:r>
             <a:r>
-              <a:rPr sz="1125" b="0">
+              <a:rPr sz="1125" b="0" i="0">
                 <a:solidFill>
                   <a:srgbClr val="1D2A3A"/>
                 </a:solidFill>
@@ -5531,7 +5531,7 @@
               <a:t>is_dropout</a:t>
             </a:r>
             <a:r>
-              <a:rPr sz="1200" b="0">
+              <a:rPr sz="1200" b="0" i="0">
                 <a:solidFill>
                   <a:srgbClr val="1D2A3A"/>
                 </a:solidFill>
@@ -5559,7 +5559,7 @@
               <a:t>—  </a:t>
             </a:r>
             <a:r>
-              <a:rPr sz="1200" b="1">
+              <a:rPr sz="1200" b="1" i="0">
                 <a:solidFill>
                   <a:srgbClr val="1F3A5F"/>
                 </a:solidFill>
@@ -5568,13 +5568,31 @@
               <a:t>Use:</a:t>
             </a:r>
             <a:r>
-              <a:rPr sz="1200" b="0">
+              <a:rPr sz="1200" b="0" i="0">
                 <a:solidFill>
                   <a:srgbClr val="1D2A3A"/>
                 </a:solidFill>
                 <a:latin typeface="Calibri"/>
               </a:rPr>
-              <a:t> decision support for *voluntary, supportive* adviser outreach within a fixed capacity</a:t>
+              <a:t> decision support for </a:t>
+            </a:r>
+            <a:r>
+              <a:rPr sz="1200" b="0" i="1">
+                <a:solidFill>
+                  <a:srgbClr val="1D2A3A"/>
+                </a:solidFill>
+                <a:latin typeface="Calibri"/>
+              </a:rPr>
+              <a:t>voluntary, supportive</a:t>
+            </a:r>
+            <a:r>
+              <a:rPr sz="1200" b="0" i="0">
+                <a:solidFill>
+                  <a:srgbClr val="1D2A3A"/>
+                </a:solidFill>
+                <a:latin typeface="Calibri"/>
+              </a:rPr>
+              <a:t> adviser outreach within a fixed capacity</a:t>
             </a:r>
           </a:p>
           <a:p>
@@ -5596,7 +5614,7 @@
               <a:t>—  </a:t>
             </a:r>
             <a:r>
-              <a:rPr sz="1200" b="1">
+              <a:rPr sz="1200" b="1" i="0">
                 <a:solidFill>
                   <a:srgbClr val="1F3A5F"/>
                 </a:solidFill>
@@ -5605,7 +5623,7 @@
               <a:t>Non-use:</a:t>
             </a:r>
             <a:r>
-              <a:rPr sz="1200" b="0">
+              <a:rPr sz="1200" b="0" i="0">
                 <a:solidFill>
                   <a:srgbClr val="1D2A3A"/>
                 </a:solidFill>
@@ -5633,7 +5651,7 @@
               <a:t>—  </a:t>
             </a:r>
             <a:r>
-              <a:rPr sz="1200" b="1">
+              <a:rPr sz="1200" b="1" i="0">
                 <a:solidFill>
                   <a:srgbClr val="1F3A5F"/>
                 </a:solidFill>
@@ -5642,7 +5660,7 @@
               <a:t>Primary metric:</a:t>
             </a:r>
             <a:r>
-              <a:rPr sz="1200" b="0">
+              <a:rPr sz="1200" b="0" i="0">
                 <a:solidFill>
                   <a:srgbClr val="1D2A3A"/>
                 </a:solidFill>
@@ -5651,7 +5669,7 @@
               <a:t> PR-AUC (imbalance: positive rate 0.321) · </a:t>
             </a:r>
             <a:r>
-              <a:rPr sz="1200" b="1">
+              <a:rPr sz="1200" b="1" i="0">
                 <a:solidFill>
                   <a:srgbClr val="1F3A5F"/>
                 </a:solidFill>
@@ -5660,7 +5678,7 @@
               <a:t>Intervention metric:</a:t>
             </a:r>
             <a:r>
-              <a:rPr sz="1200" b="0">
+              <a:rPr sz="1200" b="0" i="0">
                 <a:solidFill>
                   <a:srgbClr val="1D2A3A"/>
                 </a:solidFill>
@@ -5688,7 +5706,7 @@
               <a:t>—  </a:t>
             </a:r>
             <a:r>
-              <a:rPr sz="1200" b="1">
+              <a:rPr sz="1200" b="1" i="0">
                 <a:solidFill>
                   <a:srgbClr val="1F3A5F"/>
                 </a:solidFill>
@@ -5697,7 +5715,7 @@
               <a:t>Capacity assumption (ILLUSTRATIVE):</a:t>
             </a:r>
             <a:r>
-              <a:rPr sz="1200" b="0">
+              <a:rPr sz="1200" b="0" i="0">
                 <a:solidFill>
                   <a:srgbClr val="1D2A3A"/>
                 </a:solidFill>
@@ -5725,7 +5743,7 @@
               <a:t>—  </a:t>
             </a:r>
             <a:r>
-              <a:rPr sz="1200" b="0">
+              <a:rPr sz="1200" b="0" i="0">
                 <a:solidFill>
                   <a:srgbClr val="1D2A3A"/>
                 </a:solidFill>
@@ -6031,16 +6049,34 @@
               <a:t>—  </a:t>
             </a:r>
             <a:r>
-              <a:rPr sz="1200" b="0">
+              <a:rPr sz="1200" b="0" i="0">
                 <a:solidFill>
                   <a:srgbClr val="1D2A3A"/>
                 </a:solidFill>
                 <a:latin typeface="Calibri"/>
               </a:rPr>
-              <a:t>UCI ML Repository 697, *Predict Students' Dropout and Academic Success* (Realinho et al., 2021), </a:t>
-            </a:r>
-            <a:r>
-              <a:rPr sz="1200" b="1">
+              <a:t>UCI ML Repository 697, </a:t>
+            </a:r>
+            <a:r>
+              <a:rPr sz="1200" b="0" i="1">
+                <a:solidFill>
+                  <a:srgbClr val="1D2A3A"/>
+                </a:solidFill>
+                <a:latin typeface="Calibri"/>
+              </a:rPr>
+              <a:t>Predict Students' Dropout and Academic Success</a:t>
+            </a:r>
+            <a:r>
+              <a:rPr sz="1200" b="0" i="0">
+                <a:solidFill>
+                  <a:srgbClr val="1D2A3A"/>
+                </a:solidFill>
+                <a:latin typeface="Calibri"/>
+              </a:rPr>
+              <a:t> (Realinho et al., 2021), </a:t>
+            </a:r>
+            <a:r>
+              <a:rPr sz="1200" b="1" i="0">
                 <a:solidFill>
                   <a:srgbClr val="1F3A5F"/>
                 </a:solidFill>
@@ -6049,7 +6085,7 @@
               <a:t>CC BY 4.0</a:t>
             </a:r>
             <a:r>
-              <a:rPr sz="1200" b="0">
+              <a:rPr sz="1200" b="0" i="0">
                 <a:solidFill>
                   <a:srgbClr val="1D2A3A"/>
                 </a:solidFill>
@@ -6077,7 +6113,7 @@
               <a:t>—  </a:t>
             </a:r>
             <a:r>
-              <a:rPr sz="1200" b="0">
+              <a:rPr sz="1200" b="0" i="0">
                 <a:solidFill>
                   <a:srgbClr val="1D2A3A"/>
                 </a:solidFill>
@@ -6086,7 +6122,7 @@
               <a:t>One Portuguese higher-education institution; </a:t>
             </a:r>
             <a:r>
-              <a:rPr sz="1200" b="1">
+              <a:rPr sz="1200" b="1" i="0">
                 <a:solidFill>
                   <a:srgbClr val="1F3A5F"/>
                 </a:solidFill>
@@ -6095,7 +6131,7 @@
               <a:t>4,424</a:t>
             </a:r>
             <a:r>
-              <a:rPr sz="1200" b="0">
+              <a:rPr sz="1200" b="0" i="0">
                 <a:solidFill>
                   <a:srgbClr val="1D2A3A"/>
                 </a:solidFill>
@@ -6123,7 +6159,7 @@
               <a:t>—  </a:t>
             </a:r>
             <a:r>
-              <a:rPr sz="1200" b="0">
+              <a:rPr sz="1200" b="0" i="0">
                 <a:solidFill>
                   <a:srgbClr val="1D2A3A"/>
                 </a:solidFill>
@@ -6151,7 +6187,7 @@
               <a:t>—  </a:t>
             </a:r>
             <a:r>
-              <a:rPr sz="1200" b="0">
+              <a:rPr sz="1200" b="0" i="0">
                 <a:solidFill>
                   <a:srgbClr val="1D2A3A"/>
                 </a:solidFill>
@@ -6179,7 +6215,7 @@
               <a:t>—  </a:t>
             </a:r>
             <a:r>
-              <a:rPr sz="1200" b="0">
+              <a:rPr sz="1200" b="0" i="0">
                 <a:solidFill>
                   <a:srgbClr val="1D2A3A"/>
                 </a:solidFill>
@@ -6188,7 +6224,7 @@
               <a:t>Stratified 80/20 split, seed 42: train </a:t>
             </a:r>
             <a:r>
-              <a:rPr sz="1200" b="1">
+              <a:rPr sz="1200" b="1" i="0">
                 <a:solidFill>
                   <a:srgbClr val="1F3A5F"/>
                 </a:solidFill>
@@ -6197,7 +6233,7 @@
               <a:t>3539</a:t>
             </a:r>
             <a:r>
-              <a:rPr sz="1200" b="0">
+              <a:rPr sz="1200" b="0" i="0">
                 <a:solidFill>
                   <a:srgbClr val="1D2A3A"/>
                 </a:solidFill>
@@ -6206,7 +6242,7 @@
               <a:t> · test </a:t>
             </a:r>
             <a:r>
-              <a:rPr sz="1200" b="1">
+              <a:rPr sz="1200" b="1" i="0">
                 <a:solidFill>
                   <a:srgbClr val="1F3A5F"/>
                 </a:solidFill>
@@ -6215,7 +6251,7 @@
               <a:t>885</a:t>
             </a:r>
             <a:r>
-              <a:rPr sz="1200" b="0">
+              <a:rPr sz="1200" b="0" i="0">
                 <a:solidFill>
                   <a:srgbClr val="1D2A3A"/>
                 </a:solidFill>
@@ -6342,7 +6378,7 @@
               </a:lnSpc>
             </a:pPr>
             <a:r>
-              <a:rPr sz="975" b="0">
+              <a:rPr sz="975" b="0" i="0">
                 <a:solidFill>
                   <a:srgbClr val="B7791F"/>
                 </a:solidFill>
@@ -6646,7 +6682,7 @@
                         </a:lnSpc>
                       </a:pPr>
                       <a:r>
-                        <a:rPr sz="825" b="1" spc="130">
+                        <a:rPr sz="825" b="1" i="0" spc="130">
                           <a:solidFill>
                             <a:srgbClr val="5B6B7B"/>
                           </a:solidFill>
@@ -6678,7 +6714,7 @@
                         </a:lnSpc>
                       </a:pPr>
                       <a:r>
-                        <a:rPr sz="825" b="1" spc="130">
+                        <a:rPr sz="825" b="1" i="0" spc="130">
                           <a:solidFill>
                             <a:srgbClr val="5B6B7B"/>
                           </a:solidFill>
@@ -6710,7 +6746,7 @@
                         </a:lnSpc>
                       </a:pPr>
                       <a:r>
-                        <a:rPr sz="825" b="1" spc="130">
+                        <a:rPr sz="825" b="1" i="0" spc="130">
                           <a:solidFill>
                             <a:srgbClr val="5B6B7B"/>
                           </a:solidFill>
@@ -6744,7 +6780,7 @@
                         </a:lnSpc>
                       </a:pPr>
                       <a:r>
-                        <a:rPr sz="1125" b="0">
+                        <a:rPr sz="1125" b="0" i="0">
                           <a:solidFill>
                             <a:srgbClr val="1D2A3A"/>
                           </a:solidFill>
@@ -6776,7 +6812,7 @@
                         </a:lnSpc>
                       </a:pPr>
                       <a:r>
-                        <a:rPr sz="1125" b="1">
+                        <a:rPr sz="1125" b="1" i="0">
                           <a:solidFill>
                             <a:srgbClr val="1D2A3A"/>
                           </a:solidFill>
@@ -6808,7 +6844,7 @@
                         </a:lnSpc>
                       </a:pPr>
                       <a:r>
-                        <a:rPr sz="1125" b="0">
+                        <a:rPr sz="1125" b="0" i="0">
                           <a:solidFill>
                             <a:srgbClr val="5B6B7B"/>
                           </a:solidFill>
@@ -6842,7 +6878,7 @@
                         </a:lnSpc>
                       </a:pPr>
                       <a:r>
-                        <a:rPr sz="1125" b="0">
+                        <a:rPr sz="1125" b="0" i="0">
                           <a:solidFill>
                             <a:srgbClr val="1D2A3A"/>
                           </a:solidFill>
@@ -6874,7 +6910,7 @@
                         </a:lnSpc>
                       </a:pPr>
                       <a:r>
-                        <a:rPr sz="1125" b="1">
+                        <a:rPr sz="1125" b="1" i="0">
                           <a:solidFill>
                             <a:srgbClr val="1D2A3A"/>
                           </a:solidFill>
@@ -6906,7 +6942,7 @@
                         </a:lnSpc>
                       </a:pPr>
                       <a:r>
-                        <a:rPr sz="1125" b="0">
+                        <a:rPr sz="1125" b="0" i="0">
                           <a:solidFill>
                             <a:srgbClr val="5B6B7B"/>
                           </a:solidFill>
@@ -6940,7 +6976,7 @@
                         </a:lnSpc>
                       </a:pPr>
                       <a:r>
-                        <a:rPr sz="1125" b="0">
+                        <a:rPr sz="1125" b="0" i="0">
                           <a:solidFill>
                             <a:srgbClr val="1D2A3A"/>
                           </a:solidFill>
@@ -6972,7 +7008,7 @@
                         </a:lnSpc>
                       </a:pPr>
                       <a:r>
-                        <a:rPr sz="1125" b="1">
+                        <a:rPr sz="1125" b="1" i="0">
                           <a:solidFill>
                             <a:srgbClr val="1D2A3A"/>
                           </a:solidFill>
@@ -7004,7 +7040,7 @@
                         </a:lnSpc>
                       </a:pPr>
                       <a:r>
-                        <a:rPr sz="1125" b="1">
+                        <a:rPr sz="1125" b="1" i="0">
                           <a:solidFill>
                             <a:srgbClr val="1F3A5F"/>
                           </a:solidFill>
@@ -7038,7 +7074,7 @@
                         </a:lnSpc>
                       </a:pPr>
                       <a:r>
-                        <a:rPr sz="1125" b="0">
+                        <a:rPr sz="1125" b="0" i="0">
                           <a:solidFill>
                             <a:srgbClr val="1D2A3A"/>
                           </a:solidFill>
@@ -7070,7 +7106,7 @@
                         </a:lnSpc>
                       </a:pPr>
                       <a:r>
-                        <a:rPr sz="1125" b="1">
+                        <a:rPr sz="1125" b="1" i="0">
                           <a:solidFill>
                             <a:srgbClr val="1D2A3A"/>
                           </a:solidFill>
@@ -7102,7 +7138,7 @@
                         </a:lnSpc>
                       </a:pPr>
                       <a:r>
-                        <a:rPr sz="1125" b="1">
+                        <a:rPr sz="1125" b="1" i="0">
                           <a:solidFill>
                             <a:srgbClr val="1F3A5F"/>
                           </a:solidFill>
@@ -7111,7 +7147,7 @@
                         <a:t>no</a:t>
                       </a:r>
                       <a:r>
-                        <a:rPr sz="1125" b="0">
+                        <a:rPr sz="1125" b="0" i="0">
                           <a:solidFill>
                             <a:srgbClr val="5B6B7B"/>
                           </a:solidFill>
@@ -7145,7 +7181,7 @@
                         </a:lnSpc>
                       </a:pPr>
                       <a:r>
-                        <a:rPr sz="1125" b="0">
+                        <a:rPr sz="1125" b="0" i="0">
                           <a:solidFill>
                             <a:srgbClr val="1D2A3A"/>
                           </a:solidFill>
@@ -7177,7 +7213,7 @@
                         </a:lnSpc>
                       </a:pPr>
                       <a:r>
-                        <a:rPr sz="1125" b="1">
+                        <a:rPr sz="1125" b="1" i="0">
                           <a:solidFill>
                             <a:srgbClr val="1D2A3A"/>
                           </a:solidFill>
@@ -7209,7 +7245,7 @@
                         </a:lnSpc>
                       </a:pPr>
                       <a:r>
-                        <a:rPr sz="1125" b="1">
+                        <a:rPr sz="1125" b="1" i="0">
                           <a:solidFill>
                             <a:srgbClr val="1F3A5F"/>
                           </a:solidFill>
@@ -7218,7 +7254,7 @@
                         <a:t>no</a:t>
                       </a:r>
                       <a:r>
-                        <a:rPr sz="1125" b="0">
+                        <a:rPr sz="1125" b="0" i="0">
                           <a:solidFill>
                             <a:srgbClr val="5B6B7B"/>
                           </a:solidFill>
@@ -7281,7 +7317,7 @@
               <a:t>—  </a:t>
             </a:r>
             <a:r>
-              <a:rPr sz="1125" b="0">
+              <a:rPr sz="1125" b="0" i="0">
                 <a:solidFill>
                   <a:srgbClr val="1D2A3A"/>
                 </a:solidFill>
@@ -7290,7 +7326,7 @@
               <a:t>Enforced by </a:t>
             </a:r>
             <a:r>
-              <a:rPr sz="1050" b="0">
+              <a:rPr sz="1050" b="0" i="0">
                 <a:solidFill>
                   <a:srgbClr val="1D2A3A"/>
                 </a:solidFill>
@@ -7299,7 +7335,7 @@
               <a:t>configs/features.yaml</a:t>
             </a:r>
             <a:r>
-              <a:rPr sz="1125" b="0">
+              <a:rPr sz="1125" b="0" i="0">
                 <a:solidFill>
                   <a:srgbClr val="1D2A3A"/>
                 </a:solidFill>
@@ -7308,7 +7344,7 @@
               <a:t>, </a:t>
             </a:r>
             <a:r>
-              <a:rPr sz="1050" b="0">
+              <a:rPr sz="1050" b="0" i="0">
                 <a:solidFill>
                   <a:srgbClr val="1D2A3A"/>
                 </a:solidFill>
@@ -7317,7 +7353,7 @@
               <a:t>project_features</a:t>
             </a:r>
             <a:r>
-              <a:rPr sz="1125" b="0">
+              <a:rPr sz="1125" b="0" i="0">
                 <a:solidFill>
                   <a:srgbClr val="1D2A3A"/>
                 </a:solidFill>
@@ -7326,7 +7362,7 @@
               <a:t> / </a:t>
             </a:r>
             <a:r>
-              <a:rPr sz="1050" b="0">
+              <a:rPr sz="1050" b="0" i="0">
                 <a:solidFill>
                   <a:srgbClr val="1D2A3A"/>
                 </a:solidFill>
@@ -7335,7 +7371,7 @@
               <a:t>assert_frame_allowed</a:t>
             </a:r>
             <a:r>
-              <a:rPr sz="1125" b="0">
+              <a:rPr sz="1125" b="0" i="0">
                 <a:solidFill>
                   <a:srgbClr val="1D2A3A"/>
                 </a:solidFill>
@@ -7363,7 +7399,7 @@
               <a:t>—  </a:t>
             </a:r>
             <a:r>
-              <a:rPr sz="1125" b="1">
+              <a:rPr sz="1125" b="1" i="0">
                 <a:solidFill>
                   <a:srgbClr val="1F3A5F"/>
                 </a:solidFill>
@@ -7372,7 +7408,7 @@
               <a:t>Cost of the guard, measured:</a:t>
             </a:r>
             <a:r>
-              <a:rPr sz="1125" b="0">
+              <a:rPr sz="1125" b="0" i="0">
                 <a:solidFill>
                   <a:srgbClr val="1D2A3A"/>
                 </a:solidFill>
@@ -7381,7 +7417,7 @@
               <a:t> including the 3 ambiguous columns would add 0.036–0.039 CV PR-AUC (</a:t>
             </a:r>
             <a:r>
-              <a:rPr sz="1050" b="0">
+              <a:rPr sz="1050" b="0" i="0">
                 <a:solidFill>
                   <a:srgbClr val="1D2A3A"/>
                 </a:solidFill>
@@ -7390,7 +7426,7 @@
               <a:t>ablation_ambiguous.csv</a:t>
             </a:r>
             <a:r>
-              <a:rPr sz="1125" b="0">
+              <a:rPr sz="1125" b="0" i="0">
                 <a:solidFill>
                   <a:srgbClr val="1D2A3A"/>
                 </a:solidFill>
@@ -7418,7 +7454,7 @@
               <a:t>—  </a:t>
             </a:r>
             <a:r>
-              <a:rPr sz="1125" b="0">
+              <a:rPr sz="1125" b="0" i="0">
                 <a:solidFill>
                   <a:srgbClr val="1D2A3A"/>
                 </a:solidFill>
@@ -7427,7 +7463,7 @@
               <a:t>Excluding the 6 sensitive attributes costs at most 0.0065 PR-AUC (</a:t>
             </a:r>
             <a:r>
-              <a:rPr sz="1050" b="0">
+              <a:rPr sz="1050" b="0" i="0">
                 <a:solidFill>
                   <a:srgbClr val="1D2A3A"/>
                 </a:solidFill>
@@ -7436,7 +7472,7 @@
               <a:t>ablation_sensitive.csv</a:t>
             </a:r>
             <a:r>
-              <a:rPr sz="1125" b="0">
+              <a:rPr sz="1125" b="0" i="0">
                 <a:solidFill>
                   <a:srgbClr val="1D2A3A"/>
                 </a:solidFill>
@@ -7766,7 +7802,7 @@
               <a:t>—  </a:t>
             </a:r>
             <a:r>
-              <a:rPr sz="1125" b="0">
+              <a:rPr sz="1125" b="0" i="0">
                 <a:solidFill>
                   <a:srgbClr val="1D2A3A"/>
                 </a:solidFill>
@@ -7794,7 +7830,7 @@
               <a:t>—  </a:t>
             </a:r>
             <a:r>
-              <a:rPr sz="1125" b="0">
+              <a:rPr sz="1125" b="0" i="0">
                 <a:solidFill>
                   <a:srgbClr val="1D2A3A"/>
                 </a:solidFill>
@@ -7822,7 +7858,7 @@
               <a:t>—  </a:t>
             </a:r>
             <a:r>
-              <a:rPr sz="1125" b="0">
+              <a:rPr sz="1125" b="0" i="0">
                 <a:solidFill>
                   <a:srgbClr val="1D2A3A"/>
                 </a:solidFill>
@@ -8128,7 +8164,7 @@
               <a:t>—  </a:t>
             </a:r>
             <a:r>
-              <a:rPr sz="1125" b="1">
+              <a:rPr sz="1125" b="1" i="0">
                 <a:solidFill>
                   <a:srgbClr val="1F3A5F"/>
                 </a:solidFill>
@@ -8137,7 +8173,7 @@
               <a:t>7 stateless engineered features</a:t>
             </a:r>
             <a:r>
-              <a:rPr sz="1125" b="0">
+              <a:rPr sz="1125" b="0" i="0">
                 <a:solidFill>
                   <a:srgbClr val="1D2A3A"/>
                 </a:solidFill>
@@ -8165,7 +8201,7 @@
               <a:t>—  </a:t>
             </a:r>
             <a:r>
-              <a:rPr sz="1125" b="0">
+              <a:rPr sz="1125" b="0" i="0">
                 <a:solidFill>
                   <a:srgbClr val="1D2A3A"/>
                 </a:solidFill>
@@ -8174,7 +8210,7 @@
               <a:t>Preprocessing = median impute · scale · one-hot → </a:t>
             </a:r>
             <a:r>
-              <a:rPr sz="1125" b="1">
+              <a:rPr sz="1125" b="1" i="0">
                 <a:solidFill>
                   <a:srgbClr val="1F3A5F"/>
                 </a:solidFill>
@@ -8183,7 +8219,7 @@
               <a:t>207</a:t>
             </a:r>
             <a:r>
-              <a:rPr sz="1125" b="0">
+              <a:rPr sz="1125" b="0" i="0">
                 <a:solidFill>
                   <a:srgbClr val="1D2A3A"/>
                 </a:solidFill>
@@ -8211,7 +8247,7 @@
               <a:t>—  </a:t>
             </a:r>
             <a:r>
-              <a:rPr sz="1125" b="1">
+              <a:rPr sz="1125" b="1" i="0">
                 <a:solidFill>
                   <a:srgbClr val="1F3A5F"/>
                 </a:solidFill>
@@ -8220,7 +8256,7 @@
               <a:t>Selection:</a:t>
             </a:r>
             <a:r>
-              <a:rPr sz="1125" b="0">
+              <a:rPr sz="1125" b="0" i="0">
                 <a:solidFill>
                   <a:srgbClr val="1D2A3A"/>
                 </a:solidFill>
@@ -8248,7 +8284,7 @@
               <a:t>—  </a:t>
             </a:r>
             <a:r>
-              <a:rPr sz="1125" b="1">
+              <a:rPr sz="1125" b="1" i="0">
                 <a:solidFill>
                   <a:srgbClr val="1F3A5F"/>
                 </a:solidFill>
@@ -8257,7 +8293,7 @@
               <a:t>PCA:</a:t>
             </a:r>
             <a:r>
-              <a:rPr sz="1125" b="0">
+              <a:rPr sz="1125" b="0" i="0">
                 <a:solidFill>
                   <a:srgbClr val="1D2A3A"/>
                 </a:solidFill>
@@ -8588,7 +8624,7 @@
                         </a:lnSpc>
                       </a:pPr>
                       <a:r>
-                        <a:rPr sz="825" b="1" spc="130">
+                        <a:rPr sz="825" b="1" i="0" spc="130">
                           <a:solidFill>
                             <a:srgbClr val="5B6B7B"/>
                           </a:solidFill>
@@ -8620,7 +8656,7 @@
                         </a:lnSpc>
                       </a:pPr>
                       <a:r>
-                        <a:rPr sz="825" b="1" spc="130">
+                        <a:rPr sz="825" b="1" i="0" spc="130">
                           <a:solidFill>
                             <a:srgbClr val="5B6B7B"/>
                           </a:solidFill>
@@ -8652,7 +8688,7 @@
                         </a:lnSpc>
                       </a:pPr>
                       <a:r>
-                        <a:rPr sz="825" b="1" spc="130">
+                        <a:rPr sz="825" b="1" i="0" spc="130">
                           <a:solidFill>
                             <a:srgbClr val="5B6B7B"/>
                           </a:solidFill>
@@ -8684,7 +8720,7 @@
                         </a:lnSpc>
                       </a:pPr>
                       <a:r>
-                        <a:rPr sz="825" b="1" spc="130">
+                        <a:rPr sz="825" b="1" i="0" spc="130">
                           <a:solidFill>
                             <a:srgbClr val="5B6B7B"/>
                           </a:solidFill>
@@ -8716,7 +8752,7 @@
                         </a:lnSpc>
                       </a:pPr>
                       <a:r>
-                        <a:rPr sz="825" b="1" spc="130">
+                        <a:rPr sz="825" b="1" i="0" spc="130">
                           <a:solidFill>
                             <a:srgbClr val="5B6B7B"/>
                           </a:solidFill>
@@ -8748,7 +8784,7 @@
                         </a:lnSpc>
                       </a:pPr>
                       <a:r>
-                        <a:rPr sz="825" b="1" spc="130">
+                        <a:rPr sz="825" b="1" i="0" spc="130">
                           <a:solidFill>
                             <a:srgbClr val="5B6B7B"/>
                           </a:solidFill>
@@ -8782,7 +8818,7 @@
                         </a:lnSpc>
                       </a:pPr>
                       <a:r>
-                        <a:rPr sz="1125" b="0">
+                        <a:rPr sz="1125" b="0" i="0">
                           <a:solidFill>
                             <a:srgbClr val="1D2A3A"/>
                           </a:solidFill>
@@ -8814,7 +8850,7 @@
                         </a:lnSpc>
                       </a:pPr>
                       <a:r>
-                        <a:rPr sz="1125" b="0">
+                        <a:rPr sz="1125" b="0" i="0">
                           <a:solidFill>
                             <a:srgbClr val="1D2A3A"/>
                           </a:solidFill>
@@ -8846,7 +8882,7 @@
                         </a:lnSpc>
                       </a:pPr>
                       <a:r>
-                        <a:rPr sz="1125" b="0">
+                        <a:rPr sz="1125" b="0" i="0">
                           <a:solidFill>
                             <a:srgbClr val="1D2A3A"/>
                           </a:solidFill>
@@ -8878,7 +8914,7 @@
                         </a:lnSpc>
                       </a:pPr>
                       <a:r>
-                        <a:rPr sz="1125" b="0">
+                        <a:rPr sz="1125" b="0" i="0">
                           <a:solidFill>
                             <a:srgbClr val="1D2A3A"/>
                           </a:solidFill>
@@ -8910,7 +8946,7 @@
                         </a:lnSpc>
                       </a:pPr>
                       <a:r>
-                        <a:rPr sz="1125" b="0">
+                        <a:rPr sz="1125" b="0" i="0">
                           <a:solidFill>
                             <a:srgbClr val="1D2A3A"/>
                           </a:solidFill>
@@ -8942,7 +8978,7 @@
                         </a:lnSpc>
                       </a:pPr>
                       <a:r>
-                        <a:rPr sz="1125" b="0">
+                        <a:rPr sz="1125" b="0" i="0">
                           <a:solidFill>
                             <a:srgbClr val="1D2A3A"/>
                           </a:solidFill>
@@ -8976,7 +9012,7 @@
                         </a:lnSpc>
                       </a:pPr>
                       <a:r>
-                        <a:rPr sz="1125" b="0">
+                        <a:rPr sz="1125" b="0" i="0">
                           <a:solidFill>
                             <a:srgbClr val="1D2A3A"/>
                           </a:solidFill>
@@ -9008,7 +9044,7 @@
                         </a:lnSpc>
                       </a:pPr>
                       <a:r>
-                        <a:rPr sz="1125" b="0">
+                        <a:rPr sz="1125" b="0" i="0">
                           <a:solidFill>
                             <a:srgbClr val="1D2A3A"/>
                           </a:solidFill>
@@ -9040,7 +9076,7 @@
                         </a:lnSpc>
                       </a:pPr>
                       <a:r>
-                        <a:rPr sz="1125" b="0">
+                        <a:rPr sz="1125" b="0" i="0">
                           <a:solidFill>
                             <a:srgbClr val="1D2A3A"/>
                           </a:solidFill>
@@ -9072,7 +9108,7 @@
                         </a:lnSpc>
                       </a:pPr>
                       <a:r>
-                        <a:rPr sz="1125" b="0">
+                        <a:rPr sz="1125" b="0" i="0">
                           <a:solidFill>
                             <a:srgbClr val="1D2A3A"/>
                           </a:solidFill>
@@ -9104,7 +9140,7 @@
                         </a:lnSpc>
                       </a:pPr>
                       <a:r>
-                        <a:rPr sz="1125" b="0">
+                        <a:rPr sz="1125" b="0" i="0">
                           <a:solidFill>
                             <a:srgbClr val="1D2A3A"/>
                           </a:solidFill>
@@ -9136,7 +9172,7 @@
                         </a:lnSpc>
                       </a:pPr>
                       <a:r>
-                        <a:rPr sz="1125" b="0">
+                        <a:rPr sz="1125" b="0" i="0">
                           <a:solidFill>
                             <a:srgbClr val="1D2A3A"/>
                           </a:solidFill>
@@ -9170,7 +9206,7 @@
                         </a:lnSpc>
                       </a:pPr>
                       <a:r>
-                        <a:rPr sz="1125" b="1">
+                        <a:rPr sz="1125" b="1" i="0">
                           <a:solidFill>
                             <a:srgbClr val="1D2A3A"/>
                           </a:solidFill>
@@ -9202,7 +9238,7 @@
                         </a:lnSpc>
                       </a:pPr>
                       <a:r>
-                        <a:rPr sz="1125" b="1">
+                        <a:rPr sz="1125" b="1" i="0">
                           <a:solidFill>
                             <a:srgbClr val="1F3A5F"/>
                           </a:solidFill>
@@ -9234,7 +9270,7 @@
                         </a:lnSpc>
                       </a:pPr>
                       <a:r>
-                        <a:rPr sz="1125" b="0">
+                        <a:rPr sz="1125" b="0" i="0">
                           <a:solidFill>
                             <a:srgbClr val="1D2A3A"/>
                           </a:solidFill>
@@ -9266,7 +9302,7 @@
                         </a:lnSpc>
                       </a:pPr>
                       <a:r>
-                        <a:rPr sz="1125" b="0">
+                        <a:rPr sz="1125" b="0" i="0">
                           <a:solidFill>
                             <a:srgbClr val="1D2A3A"/>
                           </a:solidFill>
@@ -9298,7 +9334,7 @@
                         </a:lnSpc>
                       </a:pPr>
                       <a:r>
-                        <a:rPr sz="1125" b="0">
+                        <a:rPr sz="1125" b="0" i="0">
                           <a:solidFill>
                             <a:srgbClr val="1D2A3A"/>
                           </a:solidFill>
@@ -9330,7 +9366,7 @@
                         </a:lnSpc>
                       </a:pPr>
                       <a:r>
-                        <a:rPr sz="1125" b="1">
+                        <a:rPr sz="1125" b="1" i="0">
                           <a:solidFill>
                             <a:srgbClr val="1F3A5F"/>
                           </a:solidFill>
@@ -9364,7 +9400,7 @@
                         </a:lnSpc>
                       </a:pPr>
                       <a:r>
-                        <a:rPr sz="1125" b="0">
+                        <a:rPr sz="1125" b="0" i="0">
                           <a:solidFill>
                             <a:srgbClr val="1D2A3A"/>
                           </a:solidFill>
@@ -9396,7 +9432,7 @@
                         </a:lnSpc>
                       </a:pPr>
                       <a:r>
-                        <a:rPr sz="1125" b="0">
+                        <a:rPr sz="1125" b="0" i="0">
                           <a:solidFill>
                             <a:srgbClr val="1D2A3A"/>
                           </a:solidFill>
@@ -9428,7 +9464,7 @@
                         </a:lnSpc>
                       </a:pPr>
                       <a:r>
-                        <a:rPr sz="1125" b="0">
+                        <a:rPr sz="1125" b="0" i="0">
                           <a:solidFill>
                             <a:srgbClr val="1D2A3A"/>
                           </a:solidFill>
@@ -9460,7 +9496,7 @@
                         </a:lnSpc>
                       </a:pPr>
                       <a:r>
-                        <a:rPr sz="1125" b="0">
+                        <a:rPr sz="1125" b="0" i="0">
                           <a:solidFill>
                             <a:srgbClr val="1D2A3A"/>
                           </a:solidFill>
@@ -9492,7 +9528,7 @@
                         </a:lnSpc>
                       </a:pPr>
                       <a:r>
-                        <a:rPr sz="1125" b="0">
+                        <a:rPr sz="1125" b="0" i="0">
                           <a:solidFill>
                             <a:srgbClr val="1D2A3A"/>
                           </a:solidFill>
@@ -9524,7 +9560,7 @@
                         </a:lnSpc>
                       </a:pPr>
                       <a:r>
-                        <a:rPr sz="1125" b="0">
+                        <a:rPr sz="1125" b="0" i="0">
                           <a:solidFill>
                             <a:srgbClr val="1D2A3A"/>
                           </a:solidFill>
@@ -9587,7 +9623,7 @@
               <a:t>—  </a:t>
             </a:r>
             <a:r>
-              <a:rPr sz="1125" b="0">
+              <a:rPr sz="1125" b="0" i="0">
                 <a:solidFill>
                   <a:srgbClr val="1D2A3A"/>
                 </a:solidFill>
@@ -9615,7 +9651,7 @@
               <a:t>—  </a:t>
             </a:r>
             <a:r>
-              <a:rPr sz="1125" b="0">
+              <a:rPr sz="1125" b="0" i="0">
                 <a:solidFill>
                   <a:srgbClr val="1D2A3A"/>
                 </a:solidFill>
@@ -9624,7 +9660,7 @@
               <a:t>After tuning (RandomizedSearchCV, PR-AUC), all three remain within one CV std → selection by documented rule: Recall@K, then </a:t>
             </a:r>
             <a:r>
-              <a:rPr sz="1125" b="1">
+              <a:rPr sz="1125" b="1" i="0">
                 <a:solidFill>
                   <a:srgbClr val="1F3A5F"/>
                 </a:solidFill>
@@ -9633,7 +9669,7 @@
               <a:t>calibration error</a:t>
             </a:r>
             <a:r>
-              <a:rPr sz="1125" b="0">
+              <a:rPr sz="1125" b="0" i="0">
                 <a:solidFill>
                   <a:srgbClr val="1D2A3A"/>
                 </a:solidFill>
@@ -9642,7 +9678,7 @@
               <a:t>, then fairness gap, then Brier, then fit time. </a:t>
             </a:r>
             <a:r>
-              <a:rPr sz="1125" b="1">
+              <a:rPr sz="1125" b="1" i="0">
                 <a:solidFill>
                   <a:srgbClr val="1F3A5F"/>
                 </a:solidFill>
@@ -9651,7 +9687,7 @@
               <a:t>Chosen: random forest, all features</a:t>
             </a:r>
             <a:r>
-              <a:rPr sz="1125" b="0">
+              <a:rPr sz="1125" b="0" i="0">
                 <a:solidFill>
                   <a:srgbClr val="1D2A3A"/>
                 </a:solidFill>
@@ -9679,7 +9715,7 @@
               <a:t>—  </a:t>
             </a:r>
             <a:r>
-              <a:rPr sz="1125" b="0">
+              <a:rPr sz="1125" b="0" i="0">
                 <a:solidFill>
                   <a:srgbClr val="1D2A3A"/>
                 </a:solidFill>
@@ -10010,7 +10046,7 @@
                         </a:lnSpc>
                       </a:pPr>
                       <a:r>
-                        <a:rPr sz="825" b="1" spc="130">
+                        <a:rPr sz="825" b="1" i="0" spc="130">
                           <a:solidFill>
                             <a:srgbClr val="5B6B7B"/>
                           </a:solidFill>
@@ -10042,7 +10078,7 @@
                         </a:lnSpc>
                       </a:pPr>
                       <a:r>
-                        <a:rPr sz="825" b="1" spc="130">
+                        <a:rPr sz="825" b="1" i="0" spc="130">
                           <a:solidFill>
                             <a:srgbClr val="5B6B7B"/>
                           </a:solidFill>
@@ -10074,7 +10110,7 @@
                         </a:lnSpc>
                       </a:pPr>
                       <a:r>
-                        <a:rPr sz="825" b="1" spc="130">
+                        <a:rPr sz="825" b="1" i="0" spc="130">
                           <a:solidFill>
                             <a:srgbClr val="5B6B7B"/>
                           </a:solidFill>
@@ -10106,7 +10142,7 @@
                         </a:lnSpc>
                       </a:pPr>
                       <a:r>
-                        <a:rPr sz="825" b="1" spc="130">
+                        <a:rPr sz="825" b="1" i="0" spc="130">
                           <a:solidFill>
                             <a:srgbClr val="5B6B7B"/>
                           </a:solidFill>
@@ -10138,7 +10174,7 @@
                         </a:lnSpc>
                       </a:pPr>
                       <a:r>
-                        <a:rPr sz="825" b="1" spc="130">
+                        <a:rPr sz="825" b="1" i="0" spc="130">
                           <a:solidFill>
                             <a:srgbClr val="5B6B7B"/>
                           </a:solidFill>
@@ -10170,7 +10206,7 @@
                         </a:lnSpc>
                       </a:pPr>
                       <a:r>
-                        <a:rPr sz="825" b="1" spc="130">
+                        <a:rPr sz="825" b="1" i="0" spc="130">
                           <a:solidFill>
                             <a:srgbClr val="5B6B7B"/>
                           </a:solidFill>
@@ -10204,7 +10240,7 @@
                         </a:lnSpc>
                       </a:pPr>
                       <a:r>
-                        <a:rPr sz="1125" b="1">
+                        <a:rPr sz="1125" b="1" i="0">
                           <a:solidFill>
                             <a:srgbClr val="1F3A5F"/>
                           </a:solidFill>
@@ -10236,7 +10272,7 @@
                         </a:lnSpc>
                       </a:pPr>
                       <a:r>
-                        <a:rPr sz="1125" b="1">
+                        <a:rPr sz="1125" b="1" i="0">
                           <a:solidFill>
                             <a:srgbClr val="1F3A5F"/>
                           </a:solidFill>
@@ -10268,7 +10304,7 @@
                         </a:lnSpc>
                       </a:pPr>
                       <a:r>
-                        <a:rPr sz="1125" b="0">
+                        <a:rPr sz="1125" b="0" i="0">
                           <a:solidFill>
                             <a:srgbClr val="1D2A3A"/>
                           </a:solidFill>
@@ -10300,7 +10336,7 @@
                         </a:lnSpc>
                       </a:pPr>
                       <a:r>
-                        <a:rPr sz="1125" b="0">
+                        <a:rPr sz="1125" b="0" i="0">
                           <a:solidFill>
                             <a:srgbClr val="1D2A3A"/>
                           </a:solidFill>
@@ -10332,7 +10368,7 @@
                         </a:lnSpc>
                       </a:pPr>
                       <a:r>
-                        <a:rPr sz="1125" b="0">
+                        <a:rPr sz="1125" b="0" i="0">
                           <a:solidFill>
                             <a:srgbClr val="1D2A3A"/>
                           </a:solidFill>
@@ -10364,7 +10400,7 @@
                         </a:lnSpc>
                       </a:pPr>
                       <a:r>
-                        <a:rPr sz="1125" b="0">
+                        <a:rPr sz="1125" b="0" i="0">
                           <a:solidFill>
                             <a:srgbClr val="1D2A3A"/>
                           </a:solidFill>
@@ -10396,7 +10432,7 @@
                         </a:lnSpc>
                       </a:pPr>
                       <a:r>
-                        <a:rPr sz="1125" b="0">
+                        <a:rPr sz="1125" b="0" i="0">
                           <a:solidFill>
                             <a:srgbClr val="1D2A3A"/>
                           </a:solidFill>
@@ -10430,7 +10466,7 @@
                         </a:lnSpc>
                       </a:pPr>
                       <a:r>
-                        <a:rPr sz="1125" b="0">
+                        <a:rPr sz="1125" b="0" i="0">
                           <a:solidFill>
                             <a:srgbClr val="1D2A3A"/>
                           </a:solidFill>
@@ -10462,7 +10498,7 @@
                         </a:lnSpc>
                       </a:pPr>
                       <a:r>
-                        <a:rPr sz="1125" b="0">
+                        <a:rPr sz="1125" b="0" i="0">
                           <a:solidFill>
                             <a:srgbClr val="1D2A3A"/>
                           </a:solidFill>
@@ -10494,7 +10530,7 @@
                         </a:lnSpc>
                       </a:pPr>
                       <a:r>
-                        <a:rPr sz="1125" b="0">
+                        <a:rPr sz="1125" b="0" i="0">
                           <a:solidFill>
                             <a:srgbClr val="1D2A3A"/>
                           </a:solidFill>
@@ -10526,7 +10562,7 @@
                         </a:lnSpc>
                       </a:pPr>
                       <a:r>
-                        <a:rPr sz="1125" b="0">
+                        <a:rPr sz="1125" b="0" i="0">
                           <a:solidFill>
                             <a:srgbClr val="1D2A3A"/>
                           </a:solidFill>
@@ -10558,7 +10594,7 @@
                         </a:lnSpc>
                       </a:pPr>
                       <a:r>
-                        <a:rPr sz="1125" b="0">
+                        <a:rPr sz="1125" b="0" i="0">
                           <a:solidFill>
                             <a:srgbClr val="1D2A3A"/>
                           </a:solidFill>
@@ -10590,7 +10626,7 @@
                         </a:lnSpc>
                       </a:pPr>
                       <a:r>
-                        <a:rPr sz="1125" b="0">
+                        <a:rPr sz="1125" b="0" i="0">
                           <a:solidFill>
                             <a:srgbClr val="1D2A3A"/>
                           </a:solidFill>
@@ -10622,7 +10658,7 @@
                         </a:lnSpc>
                       </a:pPr>
                       <a:r>
-                        <a:rPr sz="1125" b="0">
+                        <a:rPr sz="1125" b="0" i="0">
                           <a:solidFill>
                             <a:srgbClr val="1D2A3A"/>
                           </a:solidFill>
@@ -10709,7 +10745,7 @@
               <a:t>—  </a:t>
             </a:r>
             <a:r>
-              <a:rPr sz="1125" b="0">
+              <a:rPr sz="1125" b="0" i="0">
                 <a:solidFill>
                   <a:srgbClr val="1D2A3A"/>
                 </a:solidFill>
@@ -10737,7 +10773,7 @@
               <a:t>—  </a:t>
             </a:r>
             <a:r>
-              <a:rPr sz="1125" b="1">
+              <a:rPr sz="1125" b="1" i="0">
                 <a:solidFill>
                   <a:srgbClr val="1F3A5F"/>
                 </a:solidFill>
@@ -10746,7 +10782,7 @@
               <a:t>Recall@K is capacity-bound:</a:t>
             </a:r>
             <a:r>
-              <a:rPr sz="1125" b="0">
+              <a:rPr sz="1125" b="0" i="0">
                 <a:solidFill>
                   <a:srgbClr val="1D2A3A"/>
                 </a:solidFill>
@@ -10774,7 +10810,7 @@
               <a:t>—  </a:t>
             </a:r>
             <a:r>
-              <a:rPr sz="1125" b="0">
+              <a:rPr sz="1125" b="0" i="0">
                 <a:solidFill>
                   <a:srgbClr val="1D2A3A"/>
                 </a:solidFill>
@@ -11104,7 +11140,7 @@
               <a:t>—  </a:t>
             </a:r>
             <a:r>
-              <a:rPr sz="1125" b="0">
+              <a:rPr sz="1125" b="0" i="0">
                 <a:solidFill>
                   <a:srgbClr val="1D2A3A"/>
                 </a:solidFill>
@@ -11132,7 +11168,7 @@
               <a:t>—  </a:t>
             </a:r>
             <a:r>
-              <a:rPr sz="1125" b="0">
+              <a:rPr sz="1125" b="0" i="0">
                 <a:solidFill>
                   <a:srgbClr val="1D2A3A"/>
                 </a:solidFill>
@@ -11141,7 +11177,7 @@
               <a:t>Top drivers: </a:t>
             </a:r>
             <a:r>
-              <a:rPr sz="1050" b="0">
+              <a:rPr sz="1050" b="0" i="0">
                 <a:solidFill>
                   <a:srgbClr val="1D2A3A"/>
                 </a:solidFill>
@@ -11150,7 +11186,7 @@
               <a:t>sem1_approval_rate</a:t>
             </a:r>
             <a:r>
-              <a:rPr sz="1125" b="0">
+              <a:rPr sz="1125" b="0" i="0">
                 <a:solidFill>
                   <a:srgbClr val="1D2A3A"/>
                 </a:solidFill>
@@ -11159,7 +11195,7 @@
               <a:t>, Curricular units 1st sem (approved), Curricular units 1st sem (grade), </a:t>
             </a:r>
             <a:r>
-              <a:rPr sz="1050" b="0">
+              <a:rPr sz="1050" b="0" i="0">
                 <a:solidFill>
                   <a:srgbClr val="1D2A3A"/>
                 </a:solidFill>
@@ -11168,7 +11204,7 @@
               <a:t>grade_diff_vs_admission</a:t>
             </a:r>
             <a:r>
-              <a:rPr sz="1125" b="0">
+              <a:rPr sz="1125" b="0" i="0">
                 <a:solidFill>
                   <a:srgbClr val="1D2A3A"/>
                 </a:solidFill>
@@ -11196,7 +11232,7 @@
               <a:t>—  </a:t>
             </a:r>
             <a:r>
-              <a:rPr sz="1125" b="0">
+              <a:rPr sz="1125" b="0" i="0">
                 <a:solidFill>
                   <a:srgbClr val="1D2A3A"/>
                 </a:solidFill>
@@ -11205,7 +11241,7 @@
               <a:t>Local TP / FP / FN / TN cases rendered into supportive adviser phrases (</a:t>
             </a:r>
             <a:r>
-              <a:rPr sz="1050" b="0">
+              <a:rPr sz="1050" b="0" i="0">
                 <a:solidFill>
                   <a:srgbClr val="1D2A3A"/>
                 </a:solidFill>
@@ -11214,7 +11250,7 @@
               <a:t>configs/language.yaml</a:t>
             </a:r>
             <a:r>
-              <a:rPr sz="1125" b="0">
+              <a:rPr sz="1125" b="0" i="0">
                 <a:solidFill>
                   <a:srgbClr val="1D2A3A"/>
                 </a:solidFill>
@@ -11242,7 +11278,7 @@
               <a:t>—  </a:t>
             </a:r>
             <a:r>
-              <a:rPr sz="1125" b="0">
+              <a:rPr sz="1125" b="0" i="0">
                 <a:solidFill>
                   <a:srgbClr val="1D2A3A"/>
                 </a:solidFill>

</xml_diff>